<commit_message>
docs: update PipeSD presentation artifacts
- incorporate the refreshed baseline results and figures
- regenerate the paper PDF and presentation deck
</commit_message>
<xml_diff>
--- a/docs/PipeSD.pptx
+++ b/docs/PipeSD.pptx
@@ -7564,7 +7564,7 @@
                 <a:solidFill>
                   <a:srgbClr val="FFFFFF"/>
                 </a:solidFill>
-                <a:tableStyleId>{00EA39ED-CEC4-4C0F-A5C9-E7E0E0D63DE0}</a:tableStyleId>
+                <a:tableStyleId>{D868D4DB-9B43-45AD-BB82-FD433F1471BC}</a:tableStyleId>
               </a:tblPr>
               <a:tblGrid>
                 <a:gridCol w="654400"/>
@@ -9615,7 +9615,7 @@
                 <a:cs typeface="Trebuchet MS"/>
                 <a:sym typeface="Trebuchet MS"/>
               </a:rPr>
-              <a:t>Generates a fixed number of draft tokens, uploads the whole block, and waits for NAV withoutoverlap. </a:t>
+              <a:t>Generates a fixed number of draft tokens, uploads the whole block, and waits for NAV without overlap. </a:t>
             </a:r>
             <a:endParaRPr i="1" sz="1100">
               <a:solidFill>
@@ -9767,7 +9767,7 @@
                 <a:cs typeface="Trebuchet MS"/>
                 <a:sym typeface="Trebuchet MS"/>
               </a:rPr>
-              <a:t>0.5 </a:t>
+              <a:t>0.8 </a:t>
             </a:r>
             <a:r>
               <a:rPr i="1" lang="zh-CN" sz="1100">
@@ -9962,7 +9962,7 @@
                 <a:cs typeface="Trebuchet MS"/>
                 <a:sym typeface="Trebuchet MS"/>
               </a:rPr>
-              <a:t>HumanEval:0.99  GSM8K:0.7</a:t>
+              <a:t>HumanEval:0.95  GSM8K:0.7</a:t>
             </a:r>
             <a:endParaRPr sz="1200">
               <a:solidFill>
@@ -10365,7 +10365,7 @@
                 <a:cs typeface="Trebuchet MS"/>
                 <a:sym typeface="Trebuchet MS"/>
               </a:rPr>
-              <a:t>Evaluation Reaults</a:t>
+              <a:t>Evaluation Results</a:t>
             </a:r>
             <a:endParaRPr b="1" sz="3000">
               <a:solidFill>
@@ -10396,7 +10396,7 @@
                 <a:solidFill>
                   <a:srgbClr val="FFFFFF"/>
                 </a:solidFill>
-                <a:tableStyleId>{00EA39ED-CEC4-4C0F-A5C9-E7E0E0D63DE0}</a:tableStyleId>
+                <a:tableStyleId>{D868D4DB-9B43-45AD-BB82-FD433F1471BC}</a:tableStyleId>
               </a:tblPr>
               <a:tblGrid>
                 <a:gridCol w="1649450"/>
@@ -10988,7 +10988,7 @@
                           <a:cs typeface="Trebuchet MS"/>
                           <a:sym typeface="Trebuchet MS"/>
                         </a:rPr>
-                        <a:t>773.934</a:t>
+                        <a:t>578.558</a:t>
                       </a:r>
                       <a:endParaRPr sz="1200">
                         <a:solidFill>
@@ -11067,7 +11067,7 @@
                           <a:cs typeface="Trebuchet MS"/>
                           <a:sym typeface="Trebuchet MS"/>
                         </a:rPr>
-                        <a:t>29.048</a:t>
+                        <a:t>21.643</a:t>
                       </a:r>
                       <a:endParaRPr sz="1200">
                         <a:solidFill>
@@ -11227,7 +11227,7 @@
                           <a:cs typeface="Trebuchet MS"/>
                           <a:sym typeface="Trebuchet MS"/>
                         </a:rPr>
-                        <a:t>1258.404</a:t>
+                        <a:t>548.539</a:t>
                       </a:r>
                       <a:endParaRPr sz="1200">
                         <a:solidFill>
@@ -11306,7 +11306,7 @@
                           <a:cs typeface="Trebuchet MS"/>
                           <a:sym typeface="Trebuchet MS"/>
                         </a:rPr>
-                        <a:t>39.091</a:t>
+                        <a:t>20.552</a:t>
                       </a:r>
                       <a:endParaRPr sz="1200">
                         <a:solidFill>
@@ -12183,7 +12183,7 @@
                           <a:cs typeface="Trebuchet MS"/>
                           <a:sym typeface="Trebuchet MS"/>
                         </a:rPr>
-                        <a:t>1498.874</a:t>
+                        <a:t>910.411</a:t>
                       </a:r>
                       <a:endParaRPr sz="1200">
                         <a:solidFill>
@@ -12262,7 +12262,7 @@
                           <a:cs typeface="Trebuchet MS"/>
                           <a:sym typeface="Trebuchet MS"/>
                         </a:rPr>
-                        <a:t>54.021</a:t>
+                        <a:t>36.900</a:t>
                       </a:r>
                       <a:endParaRPr sz="1200">
                         <a:solidFill>
@@ -12564,13 +12564,12 @@
           <p:cNvPicPr preferRelativeResize="0"/>
           <p:nvPr/>
         </p:nvPicPr>
-        <p:blipFill>
+        <p:blipFill rotWithShape="1">
           <a:blip r:embed="rId4">
             <a:alphaModFix/>
           </a:blip>
-          <a:stretch>
-            <a:fillRect/>
-          </a:stretch>
+          <a:srcRect b="0" l="0" r="0" t="0"/>
+          <a:stretch/>
         </p:blipFill>
         <p:spPr>
           <a:xfrm>
@@ -12844,7 +12843,31 @@
                 <a:cs typeface="Trebuchet MS"/>
                 <a:sym typeface="Trebuchet MS"/>
               </a:rPr>
-              <a:t>Evaluation Reaults</a:t>
+              <a:t>Evaluation Re</a:t>
+            </a:r>
+            <a:r>
+              <a:rPr b="1" lang="zh-CN" sz="3000">
+                <a:solidFill>
+                  <a:schemeClr val="dk1"/>
+                </a:solidFill>
+                <a:latin typeface="Trebuchet MS"/>
+                <a:ea typeface="Trebuchet MS"/>
+                <a:cs typeface="Trebuchet MS"/>
+                <a:sym typeface="Trebuchet MS"/>
+              </a:rPr>
+              <a:t>s</a:t>
+            </a:r>
+            <a:r>
+              <a:rPr b="1" lang="zh-CN" sz="3000">
+                <a:solidFill>
+                  <a:schemeClr val="dk1"/>
+                </a:solidFill>
+                <a:latin typeface="Trebuchet MS"/>
+                <a:ea typeface="Trebuchet MS"/>
+                <a:cs typeface="Trebuchet MS"/>
+                <a:sym typeface="Trebuchet MS"/>
+              </a:rPr>
+              <a:t>ults</a:t>
             </a:r>
             <a:endParaRPr b="1" sz="3000">
               <a:solidFill>
@@ -12875,7 +12898,7 @@
                 <a:solidFill>
                   <a:srgbClr val="FFFFFF"/>
                 </a:solidFill>
-                <a:tableStyleId>{00EA39ED-CEC4-4C0F-A5C9-E7E0E0D63DE0}</a:tableStyleId>
+                <a:tableStyleId>{D868D4DB-9B43-45AD-BB82-FD433F1471BC}</a:tableStyleId>
               </a:tblPr>
               <a:tblGrid>
                 <a:gridCol w="1702200"/>
@@ -14103,7 +14126,7 @@
                           <a:cs typeface="Trebuchet MS"/>
                           <a:sym typeface="Trebuchet MS"/>
                         </a:rPr>
-                        <a:t>2.955</a:t>
+                        <a:t>4.408</a:t>
                       </a:r>
                       <a:endParaRPr sz="1200">
                         <a:solidFill>
@@ -14182,7 +14205,7 @@
                           <a:cs typeface="Trebuchet MS"/>
                           <a:sym typeface="Trebuchet MS"/>
                         </a:rPr>
-                        <a:t>1052</a:t>
+                        <a:t>1058</a:t>
                       </a:r>
                       <a:endParaRPr sz="1200">
                         <a:solidFill>
@@ -14261,7 +14284,7 @@
                           <a:cs typeface="Trebuchet MS"/>
                           <a:sym typeface="Trebuchet MS"/>
                         </a:rPr>
-                        <a:t>95.1%</a:t>
+                        <a:t>94.5%</a:t>
                       </a:r>
                       <a:endParaRPr sz="1200">
                         <a:solidFill>
@@ -14340,7 +14363,7 @@
                           <a:cs typeface="Trebuchet MS"/>
                           <a:sym typeface="Trebuchet MS"/>
                         </a:rPr>
-                        <a:t>356</a:t>
+                        <a:t>240</a:t>
                       </a:r>
                       <a:endParaRPr sz="1200">
                         <a:solidFill>
@@ -14419,7 +14442,19 @@
                           <a:cs typeface="Trebuchet MS"/>
                           <a:sym typeface="Trebuchet MS"/>
                         </a:rPr>
-                        <a:t>14.3%</a:t>
+                        <a:t>20.8</a:t>
+                      </a:r>
+                      <a:r>
+                        <a:rPr lang="zh-CN" sz="1200">
+                          <a:solidFill>
+                            <a:srgbClr val="333333"/>
+                          </a:solidFill>
+                          <a:latin typeface="Trebuchet MS"/>
+                          <a:ea typeface="Trebuchet MS"/>
+                          <a:cs typeface="Trebuchet MS"/>
+                          <a:sym typeface="Trebuchet MS"/>
+                        </a:rPr>
+                        <a:t>%</a:t>
                       </a:r>
                       <a:endParaRPr sz="1200">
                         <a:solidFill>
@@ -14658,7 +14693,7 @@
                           <a:cs typeface="Trebuchet MS"/>
                           <a:sym typeface="Trebuchet MS"/>
                         </a:rPr>
-                        <a:t>2.597</a:t>
+                        <a:t>5.841</a:t>
                       </a:r>
                       <a:endParaRPr sz="1200">
                         <a:solidFill>
@@ -14737,7 +14772,7 @@
                           <a:cs typeface="Trebuchet MS"/>
                           <a:sym typeface="Trebuchet MS"/>
                         </a:rPr>
-                        <a:t>1496</a:t>
+                        <a:t>1250</a:t>
                       </a:r>
                       <a:endParaRPr sz="1200">
                         <a:solidFill>
@@ -14816,7 +14851,7 @@
                           <a:cs typeface="Trebuchet MS"/>
                           <a:sym typeface="Trebuchet MS"/>
                         </a:rPr>
-                        <a:t>66.8%</a:t>
+                        <a:t>80.0%</a:t>
                       </a:r>
                       <a:endParaRPr sz="1200">
                         <a:solidFill>
@@ -14895,7 +14930,7 @@
                           <a:cs typeface="Trebuchet MS"/>
                           <a:sym typeface="Trebuchet MS"/>
                         </a:rPr>
-                        <a:t>576</a:t>
+                        <a:t>214</a:t>
                       </a:r>
                       <a:endParaRPr sz="1200">
                         <a:solidFill>
@@ -14974,7 +15009,19 @@
                           <a:cs typeface="Trebuchet MS"/>
                           <a:sym typeface="Trebuchet MS"/>
                         </a:rPr>
-                        <a:t>11.5%</a:t>
+                        <a:t>31.3</a:t>
+                      </a:r>
+                      <a:r>
+                        <a:rPr lang="zh-CN" sz="1200">
+                          <a:solidFill>
+                            <a:srgbClr val="333333"/>
+                          </a:solidFill>
+                          <a:latin typeface="Trebuchet MS"/>
+                          <a:ea typeface="Trebuchet MS"/>
+                          <a:cs typeface="Trebuchet MS"/>
+                          <a:sym typeface="Trebuchet MS"/>
+                        </a:rPr>
+                        <a:t>%</a:t>
                       </a:r>
                       <a:endParaRPr sz="1200">
                         <a:solidFill>
@@ -16878,7 +16925,7 @@
                           <a:cs typeface="Trebuchet MS"/>
                           <a:sym typeface="Trebuchet MS"/>
                         </a:rPr>
-                        <a:t>1.830</a:t>
+                        <a:t>2.708</a:t>
                       </a:r>
                       <a:endParaRPr sz="1200">
                         <a:solidFill>
@@ -16957,7 +17004,7 @@
                           <a:cs typeface="Trebuchet MS"/>
                           <a:sym typeface="Trebuchet MS"/>
                         </a:rPr>
-                        <a:t>1464</a:t>
+                        <a:t>1263</a:t>
                       </a:r>
                       <a:endParaRPr sz="1200">
                         <a:solidFill>
@@ -17036,7 +17083,7 @@
                           <a:cs typeface="Trebuchet MS"/>
                           <a:sym typeface="Trebuchet MS"/>
                         </a:rPr>
-                        <a:t>68.3%</a:t>
+                        <a:t>79.2%</a:t>
                       </a:r>
                       <a:endParaRPr sz="1200">
                         <a:solidFill>
@@ -17115,7 +17162,7 @@
                           <a:cs typeface="Trebuchet MS"/>
                           <a:sym typeface="Trebuchet MS"/>
                         </a:rPr>
-                        <a:t>800</a:t>
+                        <a:t>466</a:t>
                       </a:r>
                       <a:endParaRPr sz="1200">
                         <a:solidFill>
@@ -17194,7 +17241,19 @@
                           <a:cs typeface="Trebuchet MS"/>
                           <a:sym typeface="Trebuchet MS"/>
                         </a:rPr>
-                        <a:t>28.1%</a:t>
+                        <a:t>36</a:t>
+                      </a:r>
+                      <a:r>
+                        <a:rPr lang="zh-CN" sz="1200">
+                          <a:solidFill>
+                            <a:srgbClr val="333333"/>
+                          </a:solidFill>
+                          <a:latin typeface="Trebuchet MS"/>
+                          <a:ea typeface="Trebuchet MS"/>
+                          <a:cs typeface="Trebuchet MS"/>
+                          <a:sym typeface="Trebuchet MS"/>
+                        </a:rPr>
+                        <a:t>.1%</a:t>
                       </a:r>
                       <a:endParaRPr sz="1200">
                         <a:solidFill>
@@ -17273,7 +17332,19 @@
                           <a:cs typeface="Trebuchet MS"/>
                           <a:sym typeface="Trebuchet MS"/>
                         </a:rPr>
-                        <a:t>64.3%</a:t>
+                        <a:t>50</a:t>
+                      </a:r>
+                      <a:r>
+                        <a:rPr lang="zh-CN" sz="1200">
+                          <a:solidFill>
+                            <a:srgbClr val="333333"/>
+                          </a:solidFill>
+                          <a:latin typeface="Trebuchet MS"/>
+                          <a:ea typeface="Trebuchet MS"/>
+                          <a:cs typeface="Trebuchet MS"/>
+                          <a:sym typeface="Trebuchet MS"/>
+                        </a:rPr>
+                        <a:t>.0%</a:t>
                       </a:r>
                       <a:endParaRPr sz="1200">
                         <a:solidFill>
@@ -26301,7 +26372,7 @@
             <a:tbl>
               <a:tblPr>
                 <a:noFill/>
-                <a:tableStyleId>{3F8CB172-22BE-437F-BA43-51FDB99822CB}</a:tableStyleId>
+                <a:tableStyleId>{E5E9AB21-EFEA-4086-BA9E-7110A75A17AB}</a:tableStyleId>
               </a:tblPr>
               <a:tblGrid>
                 <a:gridCol w="3330575"/>
@@ -27634,6 +27705,285 @@
 </file>
 
 <file path=ppt/theme/theme1.xml><?xml version="1.0" encoding="utf-8"?>
+<a:theme xmlns:a="http://schemas.openxmlformats.org/drawingml/2006/main" xmlns:r="http://schemas.openxmlformats.org/officeDocument/2006/relationships" name="Simple Light">
+  <a:themeElements>
+    <a:clrScheme name="Simple Light">
+      <a:dk1>
+        <a:srgbClr val="000000"/>
+      </a:dk1>
+      <a:lt1>
+        <a:srgbClr val="FFFFFF"/>
+      </a:lt1>
+      <a:dk2>
+        <a:srgbClr val="595959"/>
+      </a:dk2>
+      <a:lt2>
+        <a:srgbClr val="EEEEEE"/>
+      </a:lt2>
+      <a:accent1>
+        <a:srgbClr val="4285F4"/>
+      </a:accent1>
+      <a:accent2>
+        <a:srgbClr val="212121"/>
+      </a:accent2>
+      <a:accent3>
+        <a:srgbClr val="78909C"/>
+      </a:accent3>
+      <a:accent4>
+        <a:srgbClr val="FFAB40"/>
+      </a:accent4>
+      <a:accent5>
+        <a:srgbClr val="0097A7"/>
+      </a:accent5>
+      <a:accent6>
+        <a:srgbClr val="EEFF41"/>
+      </a:accent6>
+      <a:hlink>
+        <a:srgbClr val="0097A7"/>
+      </a:hlink>
+      <a:folHlink>
+        <a:srgbClr val="0097A7"/>
+      </a:folHlink>
+    </a:clrScheme>
+    <a:fontScheme name="Office">
+      <a:majorFont>
+        <a:latin typeface="Arial"/>
+        <a:ea typeface=""/>
+        <a:cs typeface=""/>
+        <a:font script="Jpan" typeface="ＭＳ Ｐゴシック"/>
+        <a:font script="Hang" typeface="맑은 고딕"/>
+        <a:font script="Hans" typeface="宋体"/>
+        <a:font script="Hant" typeface="新細明體"/>
+        <a:font script="Arab" typeface="Times New Roman"/>
+        <a:font script="Hebr" typeface="Times New Roman"/>
+        <a:font script="Thai" typeface="Angsana New"/>
+        <a:font script="Ethi" typeface="Nyala"/>
+        <a:font script="Beng" typeface="Vrinda"/>
+        <a:font script="Gujr" typeface="Shruti"/>
+        <a:font script="Khmr" typeface="MoolBoran"/>
+        <a:font script="Knda" typeface="Tunga"/>
+        <a:font script="Guru" typeface="Raavi"/>
+        <a:font script="Cans" typeface="Euphemia"/>
+        <a:font script="Cher" typeface="Plantagenet Cherokee"/>
+        <a:font script="Yiii" typeface="Microsoft Yi Baiti"/>
+        <a:font script="Tibt" typeface="Microsoft Himalaya"/>
+        <a:font script="Thaa" typeface="MV Boli"/>
+        <a:font script="Deva" typeface="Mangal"/>
+        <a:font script="Telu" typeface="Gautami"/>
+        <a:font script="Taml" typeface="Latha"/>
+        <a:font script="Syrc" typeface="Estrangelo Edessa"/>
+        <a:font script="Orya" typeface="Kalinga"/>
+        <a:font script="Mlym" typeface="Kartika"/>
+        <a:font script="Laoo" typeface="DokChampa"/>
+        <a:font script="Sinh" typeface="Iskoola Pota"/>
+        <a:font script="Mong" typeface="Mongolian Baiti"/>
+        <a:font script="Viet" typeface="Times New Roman"/>
+        <a:font script="Uigh" typeface="Microsoft Uighur"/>
+        <a:font script="Geor" typeface="Sylfaen"/>
+      </a:majorFont>
+      <a:minorFont>
+        <a:latin typeface="Arial"/>
+        <a:ea typeface=""/>
+        <a:cs typeface=""/>
+        <a:font script="Jpan" typeface="ＭＳ Ｐゴシック"/>
+        <a:font script="Hang" typeface="맑은 고딕"/>
+        <a:font script="Hans" typeface="宋体"/>
+        <a:font script="Hant" typeface="新細明體"/>
+        <a:font script="Arab" typeface="Arial"/>
+        <a:font script="Hebr" typeface="Arial"/>
+        <a:font script="Thai" typeface="Cordia New"/>
+        <a:font script="Ethi" typeface="Nyala"/>
+        <a:font script="Beng" typeface="Vrinda"/>
+        <a:font script="Gujr" typeface="Shruti"/>
+        <a:font script="Khmr" typeface="DaunPenh"/>
+        <a:font script="Knda" typeface="Tunga"/>
+        <a:font script="Guru" typeface="Raavi"/>
+        <a:font script="Cans" typeface="Euphemia"/>
+        <a:font script="Cher" typeface="Plantagenet Cherokee"/>
+        <a:font script="Yiii" typeface="Microsoft Yi Baiti"/>
+        <a:font script="Tibt" typeface="Microsoft Himalaya"/>
+        <a:font script="Thaa" typeface="MV Boli"/>
+        <a:font script="Deva" typeface="Mangal"/>
+        <a:font script="Telu" typeface="Gautami"/>
+        <a:font script="Taml" typeface="Latha"/>
+        <a:font script="Syrc" typeface="Estrangelo Edessa"/>
+        <a:font script="Orya" typeface="Kalinga"/>
+        <a:font script="Mlym" typeface="Kartika"/>
+        <a:font script="Laoo" typeface="DokChampa"/>
+        <a:font script="Sinh" typeface="Iskoola Pota"/>
+        <a:font script="Mong" typeface="Mongolian Baiti"/>
+        <a:font script="Viet" typeface="Arial"/>
+        <a:font script="Uigh" typeface="Microsoft Uighur"/>
+        <a:font script="Geor" typeface="Sylfaen"/>
+      </a:minorFont>
+    </a:fontScheme>
+    <a:fmtScheme name="Office">
+      <a:fillStyleLst>
+        <a:solidFill>
+          <a:schemeClr val="phClr"/>
+        </a:solidFill>
+        <a:gradFill rotWithShape="1">
+          <a:gsLst>
+            <a:gs pos="0">
+              <a:schemeClr val="phClr">
+                <a:tint val="50000"/>
+                <a:satMod val="300000"/>
+              </a:schemeClr>
+            </a:gs>
+            <a:gs pos="35000">
+              <a:schemeClr val="phClr">
+                <a:tint val="37000"/>
+                <a:satMod val="300000"/>
+              </a:schemeClr>
+            </a:gs>
+            <a:gs pos="100000">
+              <a:schemeClr val="phClr">
+                <a:tint val="15000"/>
+                <a:satMod val="350000"/>
+              </a:schemeClr>
+            </a:gs>
+          </a:gsLst>
+          <a:lin ang="16200000" scaled="1"/>
+        </a:gradFill>
+        <a:gradFill rotWithShape="1">
+          <a:gsLst>
+            <a:gs pos="0">
+              <a:schemeClr val="phClr">
+                <a:tint val="100000"/>
+                <a:shade val="100000"/>
+                <a:satMod val="130000"/>
+              </a:schemeClr>
+            </a:gs>
+            <a:gs pos="100000">
+              <a:schemeClr val="phClr">
+                <a:tint val="50000"/>
+                <a:shade val="100000"/>
+                <a:satMod val="350000"/>
+              </a:schemeClr>
+            </a:gs>
+          </a:gsLst>
+          <a:lin ang="16200000" scaled="0"/>
+        </a:gradFill>
+      </a:fillStyleLst>
+      <a:lnStyleLst>
+        <a:ln w="9525" cap="flat" cmpd="sng" algn="ctr">
+          <a:solidFill>
+            <a:schemeClr val="phClr">
+              <a:shade val="95000"/>
+              <a:satMod val="105000"/>
+            </a:schemeClr>
+          </a:solidFill>
+          <a:prstDash val="solid"/>
+        </a:ln>
+        <a:ln w="25400" cap="flat" cmpd="sng" algn="ctr">
+          <a:solidFill>
+            <a:schemeClr val="phClr"/>
+          </a:solidFill>
+          <a:prstDash val="solid"/>
+        </a:ln>
+        <a:ln w="38100" cap="flat" cmpd="sng" algn="ctr">
+          <a:solidFill>
+            <a:schemeClr val="phClr"/>
+          </a:solidFill>
+          <a:prstDash val="solid"/>
+        </a:ln>
+      </a:lnStyleLst>
+      <a:effectStyleLst>
+        <a:effectStyle>
+          <a:effectLst>
+            <a:outerShdw blurRad="40000" dist="20000" dir="5400000" rotWithShape="0">
+              <a:srgbClr val="000000">
+                <a:alpha val="38000"/>
+              </a:srgbClr>
+            </a:outerShdw>
+          </a:effectLst>
+        </a:effectStyle>
+        <a:effectStyle>
+          <a:effectLst>
+            <a:outerShdw blurRad="40000" dist="23000" dir="5400000" rotWithShape="0">
+              <a:srgbClr val="000000">
+                <a:alpha val="35000"/>
+              </a:srgbClr>
+            </a:outerShdw>
+          </a:effectLst>
+        </a:effectStyle>
+        <a:effectStyle>
+          <a:effectLst>
+            <a:outerShdw blurRad="40000" dist="23000" dir="5400000" rotWithShape="0">
+              <a:srgbClr val="000000">
+                <a:alpha val="35000"/>
+              </a:srgbClr>
+            </a:outerShdw>
+          </a:effectLst>
+          <a:scene3d>
+            <a:camera prst="orthographicFront">
+              <a:rot lat="0" lon="0" rev="0"/>
+            </a:camera>
+            <a:lightRig rig="threePt" dir="t">
+              <a:rot lat="0" lon="0" rev="1200000"/>
+            </a:lightRig>
+          </a:scene3d>
+          <a:sp3d>
+            <a:bevelT w="63500" h="25400"/>
+          </a:sp3d>
+        </a:effectStyle>
+      </a:effectStyleLst>
+      <a:bgFillStyleLst>
+        <a:solidFill>
+          <a:schemeClr val="phClr"/>
+        </a:solidFill>
+        <a:gradFill rotWithShape="1">
+          <a:gsLst>
+            <a:gs pos="0">
+              <a:schemeClr val="phClr">
+                <a:tint val="40000"/>
+                <a:satMod val="350000"/>
+              </a:schemeClr>
+            </a:gs>
+            <a:gs pos="40000">
+              <a:schemeClr val="phClr">
+                <a:tint val="45000"/>
+                <a:shade val="99000"/>
+                <a:satMod val="350000"/>
+              </a:schemeClr>
+            </a:gs>
+            <a:gs pos="100000">
+              <a:schemeClr val="phClr">
+                <a:shade val="20000"/>
+                <a:satMod val="255000"/>
+              </a:schemeClr>
+            </a:gs>
+          </a:gsLst>
+          <a:path path="circle">
+            <a:fillToRect l="50000" t="-80000" r="50000" b="180000"/>
+          </a:path>
+        </a:gradFill>
+        <a:gradFill rotWithShape="1">
+          <a:gsLst>
+            <a:gs pos="0">
+              <a:schemeClr val="phClr">
+                <a:tint val="80000"/>
+                <a:satMod val="300000"/>
+              </a:schemeClr>
+            </a:gs>
+            <a:gs pos="100000">
+              <a:schemeClr val="phClr">
+                <a:shade val="30000"/>
+                <a:satMod val="200000"/>
+              </a:schemeClr>
+            </a:gs>
+          </a:gsLst>
+          <a:path path="circle">
+            <a:fillToRect l="50000" t="50000" r="50000" b="50000"/>
+          </a:path>
+        </a:gradFill>
+      </a:bgFillStyleLst>
+    </a:fmtScheme>
+  </a:themeElements>
+</a:theme>
+</file>
+
+<file path=ppt/theme/theme2.xml><?xml version="1.0" encoding="utf-8"?>
 <a:theme xmlns:a="http://schemas.openxmlformats.org/drawingml/2006/main" xmlns:r="http://schemas.openxmlformats.org/officeDocument/2006/relationships">
   <a:themeElements>
     <a:clrScheme name="Default">
@@ -27910,283 +28260,4 @@
     </a:fmtScheme>
   </a:themeElements>
 </a:theme>
-</file>
-
-<file path=ppt/theme/theme2.xml><?xml version="1.0" encoding="utf-8"?>
-<a:theme xmlns:a="http://schemas.openxmlformats.org/drawingml/2006/main" xmlns:r="http://schemas.openxmlformats.org/officeDocument/2006/relationships" name="Simple Light">
-  <a:themeElements>
-    <a:clrScheme name="Simple Light">
-      <a:dk1>
-        <a:srgbClr val="000000"/>
-      </a:dk1>
-      <a:lt1>
-        <a:srgbClr val="FFFFFF"/>
-      </a:lt1>
-      <a:dk2>
-        <a:srgbClr val="595959"/>
-      </a:dk2>
-      <a:lt2>
-        <a:srgbClr val="EEEEEE"/>
-      </a:lt2>
-      <a:accent1>
-        <a:srgbClr val="4285F4"/>
-      </a:accent1>
-      <a:accent2>
-        <a:srgbClr val="212121"/>
-      </a:accent2>
-      <a:accent3>
-        <a:srgbClr val="78909C"/>
-      </a:accent3>
-      <a:accent4>
-        <a:srgbClr val="FFAB40"/>
-      </a:accent4>
-      <a:accent5>
-        <a:srgbClr val="0097A7"/>
-      </a:accent5>
-      <a:accent6>
-        <a:srgbClr val="EEFF41"/>
-      </a:accent6>
-      <a:hlink>
-        <a:srgbClr val="0097A7"/>
-      </a:hlink>
-      <a:folHlink>
-        <a:srgbClr val="0097A7"/>
-      </a:folHlink>
-    </a:clrScheme>
-    <a:fontScheme name="Office">
-      <a:majorFont>
-        <a:latin typeface="Arial"/>
-        <a:ea typeface=""/>
-        <a:cs typeface=""/>
-        <a:font script="Jpan" typeface="ＭＳ Ｐゴシック"/>
-        <a:font script="Hang" typeface="맑은 고딕"/>
-        <a:font script="Hans" typeface="宋体"/>
-        <a:font script="Hant" typeface="新細明體"/>
-        <a:font script="Arab" typeface="Times New Roman"/>
-        <a:font script="Hebr" typeface="Times New Roman"/>
-        <a:font script="Thai" typeface="Angsana New"/>
-        <a:font script="Ethi" typeface="Nyala"/>
-        <a:font script="Beng" typeface="Vrinda"/>
-        <a:font script="Gujr" typeface="Shruti"/>
-        <a:font script="Khmr" typeface="MoolBoran"/>
-        <a:font script="Knda" typeface="Tunga"/>
-        <a:font script="Guru" typeface="Raavi"/>
-        <a:font script="Cans" typeface="Euphemia"/>
-        <a:font script="Cher" typeface="Plantagenet Cherokee"/>
-        <a:font script="Yiii" typeface="Microsoft Yi Baiti"/>
-        <a:font script="Tibt" typeface="Microsoft Himalaya"/>
-        <a:font script="Thaa" typeface="MV Boli"/>
-        <a:font script="Deva" typeface="Mangal"/>
-        <a:font script="Telu" typeface="Gautami"/>
-        <a:font script="Taml" typeface="Latha"/>
-        <a:font script="Syrc" typeface="Estrangelo Edessa"/>
-        <a:font script="Orya" typeface="Kalinga"/>
-        <a:font script="Mlym" typeface="Kartika"/>
-        <a:font script="Laoo" typeface="DokChampa"/>
-        <a:font script="Sinh" typeface="Iskoola Pota"/>
-        <a:font script="Mong" typeface="Mongolian Baiti"/>
-        <a:font script="Viet" typeface="Times New Roman"/>
-        <a:font script="Uigh" typeface="Microsoft Uighur"/>
-        <a:font script="Geor" typeface="Sylfaen"/>
-      </a:majorFont>
-      <a:minorFont>
-        <a:latin typeface="Arial"/>
-        <a:ea typeface=""/>
-        <a:cs typeface=""/>
-        <a:font script="Jpan" typeface="ＭＳ Ｐゴシック"/>
-        <a:font script="Hang" typeface="맑은 고딕"/>
-        <a:font script="Hans" typeface="宋体"/>
-        <a:font script="Hant" typeface="新細明體"/>
-        <a:font script="Arab" typeface="Arial"/>
-        <a:font script="Hebr" typeface="Arial"/>
-        <a:font script="Thai" typeface="Cordia New"/>
-        <a:font script="Ethi" typeface="Nyala"/>
-        <a:font script="Beng" typeface="Vrinda"/>
-        <a:font script="Gujr" typeface="Shruti"/>
-        <a:font script="Khmr" typeface="DaunPenh"/>
-        <a:font script="Knda" typeface="Tunga"/>
-        <a:font script="Guru" typeface="Raavi"/>
-        <a:font script="Cans" typeface="Euphemia"/>
-        <a:font script="Cher" typeface="Plantagenet Cherokee"/>
-        <a:font script="Yiii" typeface="Microsoft Yi Baiti"/>
-        <a:font script="Tibt" typeface="Microsoft Himalaya"/>
-        <a:font script="Thaa" typeface="MV Boli"/>
-        <a:font script="Deva" typeface="Mangal"/>
-        <a:font script="Telu" typeface="Gautami"/>
-        <a:font script="Taml" typeface="Latha"/>
-        <a:font script="Syrc" typeface="Estrangelo Edessa"/>
-        <a:font script="Orya" typeface="Kalinga"/>
-        <a:font script="Mlym" typeface="Kartika"/>
-        <a:font script="Laoo" typeface="DokChampa"/>
-        <a:font script="Sinh" typeface="Iskoola Pota"/>
-        <a:font script="Mong" typeface="Mongolian Baiti"/>
-        <a:font script="Viet" typeface="Arial"/>
-        <a:font script="Uigh" typeface="Microsoft Uighur"/>
-        <a:font script="Geor" typeface="Sylfaen"/>
-      </a:minorFont>
-    </a:fontScheme>
-    <a:fmtScheme name="Office">
-      <a:fillStyleLst>
-        <a:solidFill>
-          <a:schemeClr val="phClr"/>
-        </a:solidFill>
-        <a:gradFill rotWithShape="1">
-          <a:gsLst>
-            <a:gs pos="0">
-              <a:schemeClr val="phClr">
-                <a:tint val="50000"/>
-                <a:satMod val="300000"/>
-              </a:schemeClr>
-            </a:gs>
-            <a:gs pos="35000">
-              <a:schemeClr val="phClr">
-                <a:tint val="37000"/>
-                <a:satMod val="300000"/>
-              </a:schemeClr>
-            </a:gs>
-            <a:gs pos="100000">
-              <a:schemeClr val="phClr">
-                <a:tint val="15000"/>
-                <a:satMod val="350000"/>
-              </a:schemeClr>
-            </a:gs>
-          </a:gsLst>
-          <a:lin ang="16200000" scaled="1"/>
-        </a:gradFill>
-        <a:gradFill rotWithShape="1">
-          <a:gsLst>
-            <a:gs pos="0">
-              <a:schemeClr val="phClr">
-                <a:tint val="100000"/>
-                <a:shade val="100000"/>
-                <a:satMod val="130000"/>
-              </a:schemeClr>
-            </a:gs>
-            <a:gs pos="100000">
-              <a:schemeClr val="phClr">
-                <a:tint val="50000"/>
-                <a:shade val="100000"/>
-                <a:satMod val="350000"/>
-              </a:schemeClr>
-            </a:gs>
-          </a:gsLst>
-          <a:lin ang="16200000" scaled="0"/>
-        </a:gradFill>
-      </a:fillStyleLst>
-      <a:lnStyleLst>
-        <a:ln w="9525" cap="flat" cmpd="sng" algn="ctr">
-          <a:solidFill>
-            <a:schemeClr val="phClr">
-              <a:shade val="95000"/>
-              <a:satMod val="105000"/>
-            </a:schemeClr>
-          </a:solidFill>
-          <a:prstDash val="solid"/>
-        </a:ln>
-        <a:ln w="25400" cap="flat" cmpd="sng" algn="ctr">
-          <a:solidFill>
-            <a:schemeClr val="phClr"/>
-          </a:solidFill>
-          <a:prstDash val="solid"/>
-        </a:ln>
-        <a:ln w="38100" cap="flat" cmpd="sng" algn="ctr">
-          <a:solidFill>
-            <a:schemeClr val="phClr"/>
-          </a:solidFill>
-          <a:prstDash val="solid"/>
-        </a:ln>
-      </a:lnStyleLst>
-      <a:effectStyleLst>
-        <a:effectStyle>
-          <a:effectLst>
-            <a:outerShdw blurRad="40000" dist="20000" dir="5400000" rotWithShape="0">
-              <a:srgbClr val="000000">
-                <a:alpha val="38000"/>
-              </a:srgbClr>
-            </a:outerShdw>
-          </a:effectLst>
-        </a:effectStyle>
-        <a:effectStyle>
-          <a:effectLst>
-            <a:outerShdw blurRad="40000" dist="23000" dir="5400000" rotWithShape="0">
-              <a:srgbClr val="000000">
-                <a:alpha val="35000"/>
-              </a:srgbClr>
-            </a:outerShdw>
-          </a:effectLst>
-        </a:effectStyle>
-        <a:effectStyle>
-          <a:effectLst>
-            <a:outerShdw blurRad="40000" dist="23000" dir="5400000" rotWithShape="0">
-              <a:srgbClr val="000000">
-                <a:alpha val="35000"/>
-              </a:srgbClr>
-            </a:outerShdw>
-          </a:effectLst>
-          <a:scene3d>
-            <a:camera prst="orthographicFront">
-              <a:rot lat="0" lon="0" rev="0"/>
-            </a:camera>
-            <a:lightRig rig="threePt" dir="t">
-              <a:rot lat="0" lon="0" rev="1200000"/>
-            </a:lightRig>
-          </a:scene3d>
-          <a:sp3d>
-            <a:bevelT w="63500" h="25400"/>
-          </a:sp3d>
-        </a:effectStyle>
-      </a:effectStyleLst>
-      <a:bgFillStyleLst>
-        <a:solidFill>
-          <a:schemeClr val="phClr"/>
-        </a:solidFill>
-        <a:gradFill rotWithShape="1">
-          <a:gsLst>
-            <a:gs pos="0">
-              <a:schemeClr val="phClr">
-                <a:tint val="40000"/>
-                <a:satMod val="350000"/>
-              </a:schemeClr>
-            </a:gs>
-            <a:gs pos="40000">
-              <a:schemeClr val="phClr">
-                <a:tint val="45000"/>
-                <a:shade val="99000"/>
-                <a:satMod val="350000"/>
-              </a:schemeClr>
-            </a:gs>
-            <a:gs pos="100000">
-              <a:schemeClr val="phClr">
-                <a:shade val="20000"/>
-                <a:satMod val="255000"/>
-              </a:schemeClr>
-            </a:gs>
-          </a:gsLst>
-          <a:path path="circle">
-            <a:fillToRect l="50000" t="-80000" r="50000" b="180000"/>
-          </a:path>
-        </a:gradFill>
-        <a:gradFill rotWithShape="1">
-          <a:gsLst>
-            <a:gs pos="0">
-              <a:schemeClr val="phClr">
-                <a:tint val="80000"/>
-                <a:satMod val="300000"/>
-              </a:schemeClr>
-            </a:gs>
-            <a:gs pos="100000">
-              <a:schemeClr val="phClr">
-                <a:shade val="30000"/>
-                <a:satMod val="200000"/>
-              </a:schemeClr>
-            </a:gs>
-          </a:gsLst>
-          <a:path path="circle">
-            <a:fillToRect l="50000" t="50000" r="50000" b="50000"/>
-          </a:path>
-        </a:gradFill>
-      </a:bgFillStyleLst>
-    </a:fmtScheme>
-  </a:themeElements>
-</a:theme>
 </file>
</xml_diff>